<commit_message>
Add Groq LLM verifier (regex-primary, opt-in, Render-safe)
</commit_message>
<xml_diff>
--- a/BhuVerify_SIH26018_Pitch_Deck.pptx
+++ b/BhuVerify_SIH26018_Pitch_Deck.pptx
@@ -3114,7 +3114,7 @@
             <a:avLst/>
           </a:prstGeom>
           <a:solidFill>
-            <a:srgbClr val="0F5C4A"/>
+            <a:srgbClr val="0A3D91"/>
           </a:solidFill>
           <a:ln>
             <a:noFill/>
@@ -3342,7 +3342,7 @@
                 </a:solidFill>
                 <a:latin typeface="Segoe UI"/>
               </a:rPr>
-              <a:t>Merge Conflict</a:t>
+              <a:t>Shadow Slayers</a:t>
             </a:r>
           </a:p>
         </p:txBody>
@@ -3446,7 +3446,7 @@
             <a:avLst/>
           </a:prstGeom>
           <a:solidFill>
-            <a:srgbClr val="B8860B"/>
+            <a:srgbClr val="D97706"/>
           </a:solidFill>
           <a:ln>
             <a:noFill/>
@@ -3726,7 +3726,7 @@
                 </a:solidFill>
                 <a:latin typeface="Segoe UI"/>
               </a:rPr>
-              <a:t>6.5s</a:t>
+              <a:t>13.2s</a:t>
             </a:r>
           </a:p>
         </p:txBody>
@@ -3854,7 +3854,7 @@
                 </a:solidFill>
                 <a:latin typeface="Segoe UI"/>
               </a:rPr>
-              <a:t>85%</a:t>
+              <a:t>72%</a:t>
             </a:r>
           </a:p>
         </p:txBody>
@@ -4148,7 +4148,7 @@
             <a:avLst/>
           </a:prstGeom>
           <a:solidFill>
-            <a:srgbClr val="0F5C4A"/>
+            <a:srgbClr val="0A3D91"/>
           </a:solidFill>
           <a:ln>
             <a:noFill/>
@@ -4210,7 +4210,7 @@
             <a:r>
               <a:rPr sz="1050" b="1">
                 <a:solidFill>
-                  <a:srgbClr val="14795F"/>
+                  <a:srgbClr val="062A63"/>
                 </a:solidFill>
                 <a:latin typeface="Segoe UI"/>
               </a:rPr>
@@ -4364,7 +4364,7 @@
             <a:avLst/>
           </a:prstGeom>
           <a:solidFill>
-            <a:srgbClr val="14795F"/>
+            <a:srgbClr val="062A63"/>
           </a:solidFill>
           <a:ln>
             <a:noFill/>
@@ -4554,7 +4554,7 @@
             <a:r>
               <a:rPr sz="850" b="1">
                 <a:solidFill>
-                  <a:srgbClr val="14795F"/>
+                  <a:srgbClr val="062A63"/>
                 </a:solidFill>
                 <a:latin typeface="Segoe UI"/>
               </a:rPr>
@@ -4578,7 +4578,7 @@
             <a:avLst/>
           </a:prstGeom>
           <a:solidFill>
-            <a:srgbClr val="14795F"/>
+            <a:srgbClr val="062A63"/>
           </a:solidFill>
           <a:ln>
             <a:noFill/>
@@ -4664,7 +4664,7 @@
             <a:avLst/>
           </a:prstGeom>
           <a:solidFill>
-            <a:srgbClr val="14795F"/>
+            <a:srgbClr val="062A63"/>
           </a:solidFill>
           <a:ln>
             <a:noFill/>
@@ -4750,7 +4750,7 @@
             <a:avLst/>
           </a:prstGeom>
           <a:solidFill>
-            <a:srgbClr val="14795F"/>
+            <a:srgbClr val="062A63"/>
           </a:solidFill>
           <a:ln>
             <a:noFill/>
@@ -4836,7 +4836,7 @@
             <a:avLst/>
           </a:prstGeom>
           <a:solidFill>
-            <a:srgbClr val="14795F"/>
+            <a:srgbClr val="062A63"/>
           </a:solidFill>
           <a:ln>
             <a:noFill/>
@@ -4922,7 +4922,7 @@
             <a:avLst/>
           </a:prstGeom>
           <a:solidFill>
-            <a:srgbClr val="14795F"/>
+            <a:srgbClr val="062A63"/>
           </a:solidFill>
           <a:ln>
             <a:noFill/>
@@ -5008,7 +5008,7 @@
             <a:avLst/>
           </a:prstGeom>
           <a:solidFill>
-            <a:srgbClr val="14795F"/>
+            <a:srgbClr val="062A63"/>
           </a:solidFill>
           <a:ln>
             <a:noFill/>
@@ -5140,7 +5140,7 @@
             <a:avLst/>
           </a:prstGeom>
           <a:solidFill>
-            <a:srgbClr val="B8860B"/>
+            <a:srgbClr val="D97706"/>
           </a:solidFill>
           <a:ln>
             <a:noFill/>
@@ -5330,7 +5330,7 @@
             <a:r>
               <a:rPr sz="850" b="1">
                 <a:solidFill>
-                  <a:srgbClr val="B8860B"/>
+                  <a:srgbClr val="D97706"/>
                 </a:solidFill>
                 <a:latin typeface="Segoe UI"/>
               </a:rPr>
@@ -5354,7 +5354,7 @@
             <a:avLst/>
           </a:prstGeom>
           <a:solidFill>
-            <a:srgbClr val="14795F"/>
+            <a:srgbClr val="062A63"/>
           </a:solidFill>
           <a:ln>
             <a:noFill/>
@@ -5440,7 +5440,7 @@
             <a:avLst/>
           </a:prstGeom>
           <a:solidFill>
-            <a:srgbClr val="14795F"/>
+            <a:srgbClr val="062A63"/>
           </a:solidFill>
           <a:ln>
             <a:noFill/>
@@ -5526,7 +5526,7 @@
             <a:avLst/>
           </a:prstGeom>
           <a:solidFill>
-            <a:srgbClr val="14795F"/>
+            <a:srgbClr val="062A63"/>
           </a:solidFill>
           <a:ln>
             <a:noFill/>
@@ -5612,7 +5612,7 @@
             <a:avLst/>
           </a:prstGeom>
           <a:solidFill>
-            <a:srgbClr val="14795F"/>
+            <a:srgbClr val="062A63"/>
           </a:solidFill>
           <a:ln>
             <a:noFill/>
@@ -5698,7 +5698,7 @@
             <a:avLst/>
           </a:prstGeom>
           <a:solidFill>
-            <a:srgbClr val="14795F"/>
+            <a:srgbClr val="062A63"/>
           </a:solidFill>
           <a:ln>
             <a:noFill/>
@@ -5784,7 +5784,7 @@
             <a:avLst/>
           </a:prstGeom>
           <a:solidFill>
-            <a:srgbClr val="14795F"/>
+            <a:srgbClr val="062A63"/>
           </a:solidFill>
           <a:ln>
             <a:noFill/>
@@ -6130,7 +6130,7 @@
             <a:avLst/>
           </a:prstGeom>
           <a:solidFill>
-            <a:srgbClr val="14795F"/>
+            <a:srgbClr val="062A63"/>
           </a:solidFill>
           <a:ln>
             <a:noFill/>
@@ -6216,7 +6216,7 @@
             <a:avLst/>
           </a:prstGeom>
           <a:solidFill>
-            <a:srgbClr val="14795F"/>
+            <a:srgbClr val="062A63"/>
           </a:solidFill>
           <a:ln>
             <a:noFill/>
@@ -6302,7 +6302,7 @@
             <a:avLst/>
           </a:prstGeom>
           <a:solidFill>
-            <a:srgbClr val="14795F"/>
+            <a:srgbClr val="062A63"/>
           </a:solidFill>
           <a:ln>
             <a:noFill/>
@@ -6388,7 +6388,7 @@
             <a:avLst/>
           </a:prstGeom>
           <a:solidFill>
-            <a:srgbClr val="14795F"/>
+            <a:srgbClr val="062A63"/>
           </a:solidFill>
           <a:ln>
             <a:noFill/>
@@ -6474,7 +6474,7 @@
             <a:avLst/>
           </a:prstGeom>
           <a:solidFill>
-            <a:srgbClr val="14795F"/>
+            <a:srgbClr val="062A63"/>
           </a:solidFill>
           <a:ln>
             <a:noFill/>
@@ -6560,7 +6560,7 @@
             <a:avLst/>
           </a:prstGeom>
           <a:solidFill>
-            <a:srgbClr val="14795F"/>
+            <a:srgbClr val="062A63"/>
           </a:solidFill>
           <a:ln>
             <a:noFill/>
@@ -6668,7 +6668,7 @@
                 </a:solidFill>
                 <a:latin typeface="Segoe UI"/>
               </a:rPr>
-              <a:t>BhuVerify · SIH26018 · Team Merge Conflict</a:t>
+              <a:t>BhuVerify · SIH26018 · Team Shadow Slayers</a:t>
             </a:r>
           </a:p>
         </p:txBody>
@@ -6792,7 +6792,7 @@
             <a:avLst/>
           </a:prstGeom>
           <a:solidFill>
-            <a:srgbClr val="0F5C4A"/>
+            <a:srgbClr val="0A3D91"/>
           </a:solidFill>
           <a:ln>
             <a:noFill/>
@@ -6854,7 +6854,7 @@
             <a:r>
               <a:rPr sz="1050" b="1">
                 <a:solidFill>
-                  <a:srgbClr val="14795F"/>
+                  <a:srgbClr val="062A63"/>
                 </a:solidFill>
                 <a:latin typeface="Segoe UI"/>
               </a:rPr>
@@ -7094,7 +7094,7 @@
             <a:avLst/>
           </a:prstGeom>
           <a:solidFill>
-            <a:srgbClr val="14795F"/>
+            <a:srgbClr val="062A63"/>
           </a:solidFill>
           <a:ln>
             <a:noFill/>
@@ -7180,7 +7180,7 @@
             <a:avLst/>
           </a:prstGeom>
           <a:solidFill>
-            <a:srgbClr val="14795F"/>
+            <a:srgbClr val="062A63"/>
           </a:solidFill>
           <a:ln>
             <a:noFill/>
@@ -7266,7 +7266,7 @@
             <a:avLst/>
           </a:prstGeom>
           <a:solidFill>
-            <a:srgbClr val="14795F"/>
+            <a:srgbClr val="062A63"/>
           </a:solidFill>
           <a:ln>
             <a:noFill/>
@@ -7352,7 +7352,7 @@
             <a:avLst/>
           </a:prstGeom>
           <a:solidFill>
-            <a:srgbClr val="14795F"/>
+            <a:srgbClr val="062A63"/>
           </a:solidFill>
           <a:ln>
             <a:noFill/>
@@ -7438,7 +7438,7 @@
             <a:avLst/>
           </a:prstGeom>
           <a:solidFill>
-            <a:srgbClr val="14795F"/>
+            <a:srgbClr val="062A63"/>
           </a:solidFill>
           <a:ln>
             <a:noFill/>
@@ -7656,7 +7656,7 @@
             <a:avLst/>
           </a:prstGeom>
           <a:solidFill>
-            <a:srgbClr val="14795F"/>
+            <a:srgbClr val="062A63"/>
           </a:solidFill>
           <a:ln>
             <a:noFill/>
@@ -7742,7 +7742,7 @@
             <a:avLst/>
           </a:prstGeom>
           <a:solidFill>
-            <a:srgbClr val="14795F"/>
+            <a:srgbClr val="062A63"/>
           </a:solidFill>
           <a:ln>
             <a:noFill/>
@@ -7828,7 +7828,7 @@
             <a:avLst/>
           </a:prstGeom>
           <a:solidFill>
-            <a:srgbClr val="14795F"/>
+            <a:srgbClr val="062A63"/>
           </a:solidFill>
           <a:ln>
             <a:noFill/>
@@ -7914,7 +7914,7 @@
             <a:avLst/>
           </a:prstGeom>
           <a:solidFill>
-            <a:srgbClr val="14795F"/>
+            <a:srgbClr val="062A63"/>
           </a:solidFill>
           <a:ln>
             <a:noFill/>
@@ -8000,7 +8000,7 @@
             <a:avLst/>
           </a:prstGeom>
           <a:solidFill>
-            <a:srgbClr val="14795F"/>
+            <a:srgbClr val="062A63"/>
           </a:solidFill>
           <a:ln>
             <a:noFill/>
@@ -8086,7 +8086,7 @@
             <a:avLst/>
           </a:prstGeom>
           <a:solidFill>
-            <a:srgbClr val="E6F2EE"/>
+            <a:srgbClr val="E8EFFA"/>
           </a:solidFill>
           <a:ln>
             <a:noFill/>
@@ -8148,7 +8148,7 @@
             <a:r>
               <a:rPr sz="1000" b="1">
                 <a:solidFill>
-                  <a:srgbClr val="0F5C4A"/>
+                  <a:srgbClr val="0A3D91"/>
                 </a:solidFill>
                 <a:latin typeface="Segoe UI"/>
               </a:rPr>
@@ -8190,11 +8190,11 @@
             <a:r>
               <a:rPr sz="2100" b="1">
                 <a:solidFill>
-                  <a:srgbClr val="0F5C4A"/>
-                </a:solidFill>
-                <a:latin typeface="Segoe UI"/>
-              </a:rPr>
-              <a:t>6.5s</a:t>
+                  <a:srgbClr val="0A3D91"/>
+                </a:solidFill>
+                <a:latin typeface="Segoe UI"/>
+              </a:rPr>
+              <a:t>13.2s</a:t>
             </a:r>
           </a:p>
         </p:txBody>
@@ -8274,11 +8274,11 @@
             <a:r>
               <a:rPr sz="2100" b="1">
                 <a:solidFill>
-                  <a:srgbClr val="0F5C4A"/>
-                </a:solidFill>
-                <a:latin typeface="Segoe UI"/>
-              </a:rPr>
-              <a:t>85%</a:t>
+                  <a:srgbClr val="0A3D91"/>
+                </a:solidFill>
+                <a:latin typeface="Segoe UI"/>
+              </a:rPr>
+              <a:t>72%</a:t>
             </a:r>
           </a:p>
         </p:txBody>
@@ -8358,11 +8358,11 @@
             <a:r>
               <a:rPr sz="2100" b="1">
                 <a:solidFill>
-                  <a:srgbClr val="0F5C4A"/>
-                </a:solidFill>
-                <a:latin typeface="Segoe UI"/>
-              </a:rPr>
-              <a:t>14</a:t>
+                  <a:srgbClr val="0A3D91"/>
+                </a:solidFill>
+                <a:latin typeface="Segoe UI"/>
+              </a:rPr>
+              <a:t>31</a:t>
             </a:r>
           </a:p>
         </p:txBody>
@@ -8442,7 +8442,7 @@
             <a:r>
               <a:rPr sz="2100" b="1">
                 <a:solidFill>
-                  <a:srgbClr val="0F5C4A"/>
+                  <a:srgbClr val="0A3D91"/>
                 </a:solidFill>
                 <a:latin typeface="Segoe UI"/>
               </a:rPr>
@@ -8526,7 +8526,7 @@
             <a:r>
               <a:rPr sz="1100" b="1">
                 <a:solidFill>
-                  <a:srgbClr val="0F5C4A"/>
+                  <a:srgbClr val="0A3D91"/>
                 </a:solidFill>
                 <a:latin typeface="Segoe UI"/>
               </a:rPr>
@@ -8572,7 +8572,7 @@
                 </a:solidFill>
                 <a:latin typeface="Segoe UI"/>
               </a:rPr>
-              <a:t>BhuVerify · SIH26018 · Team Merge Conflict</a:t>
+              <a:t>BhuVerify · SIH26018 · Team Shadow Slayers</a:t>
             </a:r>
           </a:p>
         </p:txBody>
@@ -8652,7 +8652,7 @@
             <a:avLst/>
           </a:prstGeom>
           <a:solidFill>
-            <a:srgbClr val="0F5C4A"/>
+            <a:srgbClr val="0A3D91"/>
           </a:solidFill>
           <a:ln>
             <a:noFill/>
@@ -8696,7 +8696,7 @@
             <a:avLst/>
           </a:prstGeom>
           <a:solidFill>
-            <a:srgbClr val="B8860B"/>
+            <a:srgbClr val="D97706"/>
           </a:solidFill>
           <a:ln>
             <a:noFill/>
@@ -8824,7 +8824,7 @@
             <a:avLst/>
           </a:prstGeom>
           <a:solidFill>
-            <a:srgbClr val="B8860B"/>
+            <a:srgbClr val="D97706"/>
           </a:solidFill>
           <a:ln>
             <a:noFill/>
@@ -8952,7 +8952,7 @@
             <a:avLst/>
           </a:prstGeom>
           <a:solidFill>
-            <a:srgbClr val="B8860B"/>
+            <a:srgbClr val="D97706"/>
           </a:solidFill>
           <a:ln>
             <a:noFill/>
@@ -9080,7 +9080,7 @@
             <a:avLst/>
           </a:prstGeom>
           <a:solidFill>
-            <a:srgbClr val="B8860B"/>
+            <a:srgbClr val="D97706"/>
           </a:solidFill>
           <a:ln>
             <a:noFill/>
@@ -9208,7 +9208,7 @@
             <a:avLst/>
           </a:prstGeom>
           <a:solidFill>
-            <a:srgbClr val="B8860B"/>
+            <a:srgbClr val="D97706"/>
           </a:solidFill>
           <a:ln>
             <a:noFill/>
@@ -9336,7 +9336,7 @@
             <a:avLst/>
           </a:prstGeom>
           <a:solidFill>
-            <a:srgbClr val="B8860B"/>
+            <a:srgbClr val="D97706"/>
           </a:solidFill>
           <a:ln>
             <a:noFill/>
@@ -9486,7 +9486,7 @@
                 </a:solidFill>
                 <a:latin typeface="Segoe UI"/>
               </a:rPr>
-              <a:t>SIH26018 · Smart Automation · Team Merge Conflict · working prototype available for live demonstration</a:t>
+              <a:t>SIH26018 · Smart Automation · Team Shadow Slayers · working prototype available for live demonstration</a:t>
             </a:r>
           </a:p>
         </p:txBody>
@@ -9568,7 +9568,7 @@
             <a:avLst/>
           </a:prstGeom>
           <a:solidFill>
-            <a:srgbClr val="0F5C4A"/>
+            <a:srgbClr val="0A3D91"/>
           </a:solidFill>
           <a:ln>
             <a:noFill/>
@@ -9630,7 +9630,7 @@
             <a:r>
               <a:rPr sz="1050" b="1">
                 <a:solidFill>
-                  <a:srgbClr val="14795F"/>
+                  <a:srgbClr val="062A63"/>
                 </a:solidFill>
                 <a:latin typeface="Segoe UI"/>
               </a:rPr>
@@ -9822,7 +9822,7 @@
             <a:avLst/>
           </a:prstGeom>
           <a:solidFill>
-            <a:srgbClr val="14795F"/>
+            <a:srgbClr val="062A63"/>
           </a:solidFill>
           <a:ln>
             <a:noFill/>
@@ -9950,7 +9950,7 @@
             <a:avLst/>
           </a:prstGeom>
           <a:solidFill>
-            <a:srgbClr val="14795F"/>
+            <a:srgbClr val="062A63"/>
           </a:solidFill>
           <a:ln>
             <a:noFill/>
@@ -10078,7 +10078,7 @@
             <a:avLst/>
           </a:prstGeom>
           <a:solidFill>
-            <a:srgbClr val="14795F"/>
+            <a:srgbClr val="062A63"/>
           </a:solidFill>
           <a:ln>
             <a:noFill/>
@@ -10206,7 +10206,7 @@
             <a:avLst/>
           </a:prstGeom>
           <a:solidFill>
-            <a:srgbClr val="14795F"/>
+            <a:srgbClr val="062A63"/>
           </a:solidFill>
           <a:ln>
             <a:noFill/>
@@ -10334,7 +10334,7 @@
             <a:avLst/>
           </a:prstGeom>
           <a:solidFill>
-            <a:srgbClr val="14795F"/>
+            <a:srgbClr val="062A63"/>
           </a:solidFill>
           <a:ln>
             <a:noFill/>
@@ -10636,7 +10636,7 @@
             <a:avLst/>
           </a:prstGeom>
           <a:solidFill>
-            <a:srgbClr val="14795F"/>
+            <a:srgbClr val="062A63"/>
           </a:solidFill>
           <a:ln>
             <a:noFill/>
@@ -10722,7 +10722,7 @@
             <a:avLst/>
           </a:prstGeom>
           <a:solidFill>
-            <a:srgbClr val="14795F"/>
+            <a:srgbClr val="062A63"/>
           </a:solidFill>
           <a:ln>
             <a:noFill/>
@@ -10808,7 +10808,7 @@
             <a:avLst/>
           </a:prstGeom>
           <a:solidFill>
-            <a:srgbClr val="14795F"/>
+            <a:srgbClr val="062A63"/>
           </a:solidFill>
           <a:ln>
             <a:noFill/>
@@ -10894,7 +10894,7 @@
             <a:avLst/>
           </a:prstGeom>
           <a:solidFill>
-            <a:srgbClr val="14795F"/>
+            <a:srgbClr val="062A63"/>
           </a:solidFill>
           <a:ln>
             <a:noFill/>
@@ -10980,7 +10980,7 @@
             <a:avLst/>
           </a:prstGeom>
           <a:solidFill>
-            <a:srgbClr val="14795F"/>
+            <a:srgbClr val="062A63"/>
           </a:solidFill>
           <a:ln>
             <a:noFill/>
@@ -11066,7 +11066,7 @@
             <a:avLst/>
           </a:prstGeom>
           <a:solidFill>
-            <a:srgbClr val="14795F"/>
+            <a:srgbClr val="062A63"/>
           </a:solidFill>
           <a:ln>
             <a:noFill/>
@@ -11152,7 +11152,7 @@
             <a:avLst/>
           </a:prstGeom>
           <a:solidFill>
-            <a:srgbClr val="14795F"/>
+            <a:srgbClr val="062A63"/>
           </a:solidFill>
           <a:ln>
             <a:noFill/>
@@ -11238,7 +11238,7 @@
             <a:avLst/>
           </a:prstGeom>
           <a:solidFill>
-            <a:srgbClr val="14795F"/>
+            <a:srgbClr val="062A63"/>
           </a:solidFill>
           <a:ln>
             <a:noFill/>
@@ -11324,7 +11324,7 @@
             <a:avLst/>
           </a:prstGeom>
           <a:solidFill>
-            <a:srgbClr val="14795F"/>
+            <a:srgbClr val="062A63"/>
           </a:solidFill>
           <a:ln>
             <a:noFill/>
@@ -11432,7 +11432,7 @@
                 </a:solidFill>
                 <a:latin typeface="Segoe UI"/>
               </a:rPr>
-              <a:t>BhuVerify · SIH26018 · Team Merge Conflict</a:t>
+              <a:t>BhuVerify · SIH26018 · Team Shadow Slayers</a:t>
             </a:r>
           </a:p>
         </p:txBody>
@@ -11556,7 +11556,7 @@
             <a:avLst/>
           </a:prstGeom>
           <a:solidFill>
-            <a:srgbClr val="0F5C4A"/>
+            <a:srgbClr val="0A3D91"/>
           </a:solidFill>
           <a:ln>
             <a:noFill/>
@@ -11618,7 +11618,7 @@
             <a:r>
               <a:rPr sz="1050" b="1">
                 <a:solidFill>
-                  <a:srgbClr val="14795F"/>
+                  <a:srgbClr val="062A63"/>
                 </a:solidFill>
                 <a:latin typeface="Segoe UI"/>
               </a:rPr>
@@ -11858,7 +11858,7 @@
             <a:avLst/>
           </a:prstGeom>
           <a:solidFill>
-            <a:srgbClr val="14795F"/>
+            <a:srgbClr val="062A63"/>
           </a:solidFill>
           <a:ln>
             <a:noFill/>
@@ -11944,7 +11944,7 @@
             <a:avLst/>
           </a:prstGeom>
           <a:solidFill>
-            <a:srgbClr val="14795F"/>
+            <a:srgbClr val="062A63"/>
           </a:solidFill>
           <a:ln>
             <a:noFill/>
@@ -12030,7 +12030,7 @@
             <a:avLst/>
           </a:prstGeom>
           <a:solidFill>
-            <a:srgbClr val="14795F"/>
+            <a:srgbClr val="062A63"/>
           </a:solidFill>
           <a:ln>
             <a:noFill/>
@@ -12116,7 +12116,7 @@
             <a:avLst/>
           </a:prstGeom>
           <a:solidFill>
-            <a:srgbClr val="14795F"/>
+            <a:srgbClr val="062A63"/>
           </a:solidFill>
           <a:ln>
             <a:noFill/>
@@ -12202,7 +12202,7 @@
             <a:avLst/>
           </a:prstGeom>
           <a:solidFill>
-            <a:srgbClr val="14795F"/>
+            <a:srgbClr val="062A63"/>
           </a:solidFill>
           <a:ln>
             <a:noFill/>
@@ -12420,7 +12420,7 @@
             <a:avLst/>
           </a:prstGeom>
           <a:solidFill>
-            <a:srgbClr val="14795F"/>
+            <a:srgbClr val="062A63"/>
           </a:solidFill>
           <a:ln>
             <a:noFill/>
@@ -12506,7 +12506,7 @@
             <a:avLst/>
           </a:prstGeom>
           <a:solidFill>
-            <a:srgbClr val="14795F"/>
+            <a:srgbClr val="062A63"/>
           </a:solidFill>
           <a:ln>
             <a:noFill/>
@@ -12592,7 +12592,7 @@
             <a:avLst/>
           </a:prstGeom>
           <a:solidFill>
-            <a:srgbClr val="14795F"/>
+            <a:srgbClr val="062A63"/>
           </a:solidFill>
           <a:ln>
             <a:noFill/>
@@ -12678,7 +12678,7 @@
             <a:avLst/>
           </a:prstGeom>
           <a:solidFill>
-            <a:srgbClr val="14795F"/>
+            <a:srgbClr val="062A63"/>
           </a:solidFill>
           <a:ln>
             <a:noFill/>
@@ -12764,7 +12764,7 @@
             <a:avLst/>
           </a:prstGeom>
           <a:solidFill>
-            <a:srgbClr val="14795F"/>
+            <a:srgbClr val="062A63"/>
           </a:solidFill>
           <a:ln>
             <a:noFill/>
@@ -12850,7 +12850,7 @@
             <a:avLst/>
           </a:prstGeom>
           <a:solidFill>
-            <a:srgbClr val="E6F2EE"/>
+            <a:srgbClr val="E8EFFA"/>
           </a:solidFill>
           <a:ln>
             <a:noFill/>
@@ -12912,7 +12912,7 @@
             <a:r>
               <a:rPr sz="1000" b="1">
                 <a:solidFill>
-                  <a:srgbClr val="0F5C4A"/>
+                  <a:srgbClr val="0A3D91"/>
                 </a:solidFill>
                 <a:latin typeface="Segoe UI"/>
               </a:rPr>
@@ -12954,7 +12954,7 @@
             <a:r>
               <a:rPr sz="1900" b="1">
                 <a:solidFill>
-                  <a:srgbClr val="0F5C4A"/>
+                  <a:srgbClr val="0A3D91"/>
                 </a:solidFill>
                 <a:latin typeface="Segoe UI"/>
               </a:rPr>
@@ -13118,7 +13118,7 @@
                 </a:solidFill>
                 <a:latin typeface="Segoe UI"/>
               </a:rPr>
-              <a:t>BhuVerify · SIH26018 · Team Merge Conflict</a:t>
+              <a:t>BhuVerify · SIH26018 · Team Shadow Slayers</a:t>
             </a:r>
           </a:p>
         </p:txBody>
@@ -13242,7 +13242,7 @@
             <a:avLst/>
           </a:prstGeom>
           <a:solidFill>
-            <a:srgbClr val="0F5C4A"/>
+            <a:srgbClr val="0A3D91"/>
           </a:solidFill>
           <a:ln>
             <a:noFill/>
@@ -13304,7 +13304,7 @@
             <a:r>
               <a:rPr sz="1050" b="1">
                 <a:solidFill>
-                  <a:srgbClr val="14795F"/>
+                  <a:srgbClr val="062A63"/>
                 </a:solidFill>
                 <a:latin typeface="Segoe UI"/>
               </a:rPr>
@@ -13458,7 +13458,7 @@
             <a:avLst/>
           </a:prstGeom>
           <a:solidFill>
-            <a:srgbClr val="0F5C4A"/>
+            <a:srgbClr val="0A3D91"/>
           </a:solidFill>
           <a:ln>
             <a:noFill/>
@@ -13646,7 +13646,7 @@
             <a:r>
               <a:rPr sz="1050" b="1">
                 <a:solidFill>
-                  <a:srgbClr val="14795F"/>
+                  <a:srgbClr val="062A63"/>
                 </a:solidFill>
                 <a:latin typeface="Segoe UI"/>
               </a:rPr>
@@ -13716,7 +13716,7 @@
             <a:avLst/>
           </a:prstGeom>
           <a:solidFill>
-            <a:srgbClr val="0F5C4A"/>
+            <a:srgbClr val="0A3D91"/>
           </a:solidFill>
           <a:ln>
             <a:noFill/>
@@ -13904,7 +13904,7 @@
             <a:r>
               <a:rPr sz="1050" b="1">
                 <a:solidFill>
-                  <a:srgbClr val="14795F"/>
+                  <a:srgbClr val="062A63"/>
                 </a:solidFill>
                 <a:latin typeface="Segoe UI"/>
               </a:rPr>
@@ -13974,7 +13974,7 @@
             <a:avLst/>
           </a:prstGeom>
           <a:solidFill>
-            <a:srgbClr val="0F5C4A"/>
+            <a:srgbClr val="0A3D91"/>
           </a:solidFill>
           <a:ln>
             <a:noFill/>
@@ -14162,7 +14162,7 @@
             <a:r>
               <a:rPr sz="1050" b="1">
                 <a:solidFill>
-                  <a:srgbClr val="14795F"/>
+                  <a:srgbClr val="062A63"/>
                 </a:solidFill>
                 <a:latin typeface="Segoe UI"/>
               </a:rPr>
@@ -14232,7 +14232,7 @@
             <a:avLst/>
           </a:prstGeom>
           <a:solidFill>
-            <a:srgbClr val="0F5C4A"/>
+            <a:srgbClr val="0A3D91"/>
           </a:solidFill>
           <a:ln>
             <a:noFill/>
@@ -14420,7 +14420,7 @@
             <a:r>
               <a:rPr sz="1050" b="1">
                 <a:solidFill>
-                  <a:srgbClr val="14795F"/>
+                  <a:srgbClr val="062A63"/>
                 </a:solidFill>
                 <a:latin typeface="Segoe UI"/>
               </a:rPr>
@@ -14490,7 +14490,7 @@
             <a:avLst/>
           </a:prstGeom>
           <a:solidFill>
-            <a:srgbClr val="0F5C4A"/>
+            <a:srgbClr val="0A3D91"/>
           </a:solidFill>
           <a:ln>
             <a:noFill/>
@@ -14678,7 +14678,7 @@
             <a:r>
               <a:rPr sz="1050" b="1">
                 <a:solidFill>
-                  <a:srgbClr val="14795F"/>
+                  <a:srgbClr val="062A63"/>
                 </a:solidFill>
                 <a:latin typeface="Segoe UI"/>
               </a:rPr>
@@ -14748,7 +14748,7 @@
             <a:avLst/>
           </a:prstGeom>
           <a:solidFill>
-            <a:srgbClr val="0F5C4A"/>
+            <a:srgbClr val="0A3D91"/>
           </a:solidFill>
           <a:ln>
             <a:noFill/>
@@ -14936,7 +14936,7 @@
             <a:r>
               <a:rPr sz="1050" b="1">
                 <a:solidFill>
-                  <a:srgbClr val="14795F"/>
+                  <a:srgbClr val="062A63"/>
                 </a:solidFill>
                 <a:latin typeface="Segoe UI"/>
               </a:rPr>
@@ -15006,7 +15006,7 @@
             <a:avLst/>
           </a:prstGeom>
           <a:solidFill>
-            <a:srgbClr val="0F5C4A"/>
+            <a:srgbClr val="0A3D91"/>
           </a:solidFill>
           <a:ln>
             <a:noFill/>
@@ -15194,7 +15194,7 @@
             <a:r>
               <a:rPr sz="1050" b="1">
                 <a:solidFill>
-                  <a:srgbClr val="14795F"/>
+                  <a:srgbClr val="062A63"/>
                 </a:solidFill>
                 <a:latin typeface="Segoe UI"/>
               </a:rPr>
@@ -15264,7 +15264,7 @@
             <a:avLst/>
           </a:prstGeom>
           <a:solidFill>
-            <a:srgbClr val="0F5C4A"/>
+            <a:srgbClr val="0A3D91"/>
           </a:solidFill>
           <a:ln>
             <a:noFill/>
@@ -15452,7 +15452,7 @@
             <a:r>
               <a:rPr sz="1050" b="1">
                 <a:solidFill>
-                  <a:srgbClr val="14795F"/>
+                  <a:srgbClr val="062A63"/>
                 </a:solidFill>
                 <a:latin typeface="Segoe UI"/>
               </a:rPr>
@@ -15522,7 +15522,7 @@
             <a:avLst/>
           </a:prstGeom>
           <a:solidFill>
-            <a:srgbClr val="0F5C4A"/>
+            <a:srgbClr val="0A3D91"/>
           </a:solidFill>
           <a:ln>
             <a:noFill/>
@@ -15710,7 +15710,7 @@
             <a:r>
               <a:rPr sz="1050" b="1">
                 <a:solidFill>
-                  <a:srgbClr val="14795F"/>
+                  <a:srgbClr val="062A63"/>
                 </a:solidFill>
                 <a:latin typeface="Segoe UI"/>
               </a:rPr>
@@ -15798,7 +15798,7 @@
                 </a:solidFill>
                 <a:latin typeface="Segoe UI"/>
               </a:rPr>
-              <a:t>BhuVerify · SIH26018 · Team Merge Conflict</a:t>
+              <a:t>BhuVerify · SIH26018 · Team Shadow Slayers</a:t>
             </a:r>
           </a:p>
         </p:txBody>
@@ -15922,7 +15922,7 @@
             <a:avLst/>
           </a:prstGeom>
           <a:solidFill>
-            <a:srgbClr val="0F5C4A"/>
+            <a:srgbClr val="0A3D91"/>
           </a:solidFill>
           <a:ln>
             <a:noFill/>
@@ -15984,7 +15984,7 @@
             <a:r>
               <a:rPr sz="1050" b="1">
                 <a:solidFill>
-                  <a:srgbClr val="14795F"/>
+                  <a:srgbClr val="062A63"/>
                 </a:solidFill>
                 <a:latin typeface="Segoe UI"/>
               </a:rPr>
@@ -16374,7 +16374,7 @@
                 </a:solidFill>
                 <a:latin typeface="Segoe UI"/>
               </a:rPr>
-              <a:t>1 hit</a:t>
+              <a:t>6 hit</a:t>
             </a:r>
           </a:p>
         </p:txBody>
@@ -16978,7 +16978,7 @@
                 </a:solidFill>
                 <a:latin typeface="Segoe UI"/>
               </a:rPr>
-              <a:t>1 hit</a:t>
+              <a:t>2 hit</a:t>
             </a:r>
           </a:p>
         </p:txBody>
@@ -17884,7 +17884,7 @@
                 </a:solidFill>
                 <a:latin typeface="Segoe UI"/>
               </a:rPr>
-              <a:t>1 hit</a:t>
+              <a:t>2 hit</a:t>
             </a:r>
           </a:p>
         </p:txBody>
@@ -18186,7 +18186,7 @@
                 </a:solidFill>
                 <a:latin typeface="Segoe UI"/>
               </a:rPr>
-              <a:t>2 hit</a:t>
+              <a:t>11 hit</a:t>
             </a:r>
           </a:p>
         </p:txBody>
@@ -18252,7 +18252,7 @@
             <a:avLst/>
           </a:prstGeom>
           <a:solidFill>
-            <a:srgbClr val="14795F"/>
+            <a:srgbClr val="062A63"/>
           </a:solidFill>
           <a:ln>
             <a:noFill/>
@@ -18314,7 +18314,7 @@
             <a:r>
               <a:rPr sz="1150" b="1">
                 <a:solidFill>
-                  <a:srgbClr val="0F5C4A"/>
+                  <a:srgbClr val="0A3D91"/>
                 </a:solidFill>
                 <a:latin typeface="Segoe UI"/>
               </a:rPr>
@@ -18704,7 +18704,7 @@
                 </a:solidFill>
                 <a:latin typeface="Segoe UI"/>
               </a:rPr>
-              <a:t>2 hit</a:t>
+              <a:t>3 hit</a:t>
             </a:r>
           </a:p>
         </p:txBody>
@@ -19109,7 +19109,7 @@
                 </a:solidFill>
                 <a:latin typeface="Segoe UI"/>
               </a:rPr>
-              <a:t>BhuVerify · SIH26018 · Team Merge Conflict</a:t>
+              <a:t>BhuVerify · SIH26018 · Team Shadow Slayers</a:t>
             </a:r>
           </a:p>
         </p:txBody>
@@ -19233,7 +19233,7 @@
             <a:avLst/>
           </a:prstGeom>
           <a:solidFill>
-            <a:srgbClr val="0F5C4A"/>
+            <a:srgbClr val="0A3D91"/>
           </a:solidFill>
           <a:ln>
             <a:noFill/>
@@ -19295,7 +19295,7 @@
             <a:r>
               <a:rPr sz="1050" b="1">
                 <a:solidFill>
-                  <a:srgbClr val="14795F"/>
+                  <a:srgbClr val="062A63"/>
                 </a:solidFill>
                 <a:latin typeface="Segoe UI"/>
               </a:rPr>
@@ -19449,7 +19449,7 @@
             <a:avLst/>
           </a:prstGeom>
           <a:solidFill>
-            <a:srgbClr val="14795F"/>
+            <a:srgbClr val="062A63"/>
           </a:solidFill>
           <a:ln>
             <a:noFill/>
@@ -19553,11 +19553,11 @@
             <a:r>
               <a:rPr sz="2400" b="1">
                 <a:solidFill>
-                  <a:srgbClr val="14795F"/>
-                </a:solidFill>
-                <a:latin typeface="Segoe UI"/>
-              </a:rPr>
-              <a:t>6</a:t>
+                  <a:srgbClr val="062A63"/>
+                </a:solidFill>
+                <a:latin typeface="Segoe UI"/>
+              </a:rPr>
+              <a:t>12</a:t>
             </a:r>
           </a:p>
         </p:txBody>
@@ -19665,7 +19665,7 @@
             <a:avLst/>
           </a:prstGeom>
           <a:solidFill>
-            <a:srgbClr val="14795F"/>
+            <a:srgbClr val="062A63"/>
           </a:solidFill>
           <a:ln>
             <a:noFill/>
@@ -19769,11 +19769,11 @@
             <a:r>
               <a:rPr sz="2400" b="1">
                 <a:solidFill>
-                  <a:srgbClr val="14795F"/>
-                </a:solidFill>
-                <a:latin typeface="Segoe UI"/>
-              </a:rPr>
-              <a:t>85.2%</a:t>
+                  <a:srgbClr val="062A63"/>
+                </a:solidFill>
+                <a:latin typeface="Segoe UI"/>
+              </a:rPr>
+              <a:t>72.0%</a:t>
             </a:r>
           </a:p>
         </p:txBody>
@@ -19989,7 +19989,7 @@
                 </a:solidFill>
                 <a:latin typeface="Segoe UI"/>
               </a:rPr>
-              <a:t>14</a:t>
+              <a:t>31</a:t>
             </a:r>
           </a:p>
         </p:txBody>
@@ -20031,7 +20031,7 @@
                 </a:solidFill>
                 <a:latin typeface="Segoe UI"/>
               </a:rPr>
-              <a:t>5 high or critical</a:t>
+              <a:t>12 high or critical</a:t>
             </a:r>
           </a:p>
         </p:txBody>
@@ -20097,7 +20097,7 @@
             <a:avLst/>
           </a:prstGeom>
           <a:solidFill>
-            <a:srgbClr val="14795F"/>
+            <a:srgbClr val="062A63"/>
           </a:solidFill>
           <a:ln>
             <a:noFill/>
@@ -20201,11 +20201,11 @@
             <a:r>
               <a:rPr sz="2400" b="1">
                 <a:solidFill>
-                  <a:srgbClr val="14795F"/>
-                </a:solidFill>
-                <a:latin typeface="Segoe UI"/>
-              </a:rPr>
-              <a:t>100%</a:t>
+                  <a:srgbClr val="062A63"/>
+                </a:solidFill>
+                <a:latin typeface="Segoe UI"/>
+              </a:rPr>
+              <a:t>50%</a:t>
             </a:r>
           </a:p>
         </p:txBody>
@@ -20247,7 +20247,7 @@
                 </a:solidFill>
                 <a:latin typeface="Segoe UI"/>
               </a:rPr>
-              <a:t>6/6 records matched a polygon</a:t>
+              <a:t>6/12 records matched a polygon</a:t>
             </a:r>
           </a:p>
         </p:txBody>
@@ -20313,7 +20313,7 @@
             <a:avLst/>
           </a:prstGeom>
           <a:solidFill>
-            <a:srgbClr val="B8860B"/>
+            <a:srgbClr val="D97706"/>
           </a:solidFill>
           <a:ln>
             <a:noFill/>
@@ -20417,11 +20417,11 @@
             <a:r>
               <a:rPr sz="2400" b="1">
                 <a:solidFill>
-                  <a:srgbClr val="B8860B"/>
-                </a:solidFill>
-                <a:latin typeface="Segoe UI"/>
-              </a:rPr>
-              <a:t>6.5s</a:t>
+                  <a:srgbClr val="D97706"/>
+                </a:solidFill>
+                <a:latin typeface="Segoe UI"/>
+              </a:rPr>
+              <a:t>13.2s</a:t>
             </a:r>
           </a:p>
         </p:txBody>
@@ -20463,7 +20463,7 @@
                 </a:solidFill>
                 <a:latin typeface="Segoe UI"/>
               </a:rPr>
-              <a:t>budget 10s · slowest 8.1s</a:t>
+              <a:t>budget 10s · slowest 76.4s</a:t>
             </a:r>
           </a:p>
         </p:txBody>
@@ -20529,7 +20529,7 @@
             <a:avLst/>
           </a:prstGeom>
           <a:solidFill>
-            <a:srgbClr val="14795F"/>
+            <a:srgbClr val="062A63"/>
           </a:solidFill>
           <a:ln>
             <a:noFill/>
@@ -20633,11 +20633,11 @@
             <a:r>
               <a:rPr sz="2400" b="1">
                 <a:solidFill>
-                  <a:srgbClr val="14795F"/>
-                </a:solidFill>
-                <a:latin typeface="Segoe UI"/>
-              </a:rPr>
-              <a:t>147</a:t>
+                  <a:srgbClr val="062A63"/>
+                </a:solidFill>
+                <a:latin typeface="Segoe UI"/>
+              </a:rPr>
+              <a:t>317</a:t>
             </a:r>
           </a:p>
         </p:txBody>
@@ -20745,7 +20745,7 @@
             <a:avLst/>
           </a:prstGeom>
           <a:solidFill>
-            <a:srgbClr val="14795F"/>
+            <a:srgbClr val="062A63"/>
           </a:solidFill>
           <a:ln>
             <a:noFill/>
@@ -20849,11 +20849,11 @@
             <a:r>
               <a:rPr sz="2400" b="1">
                 <a:solidFill>
-                  <a:srgbClr val="14795F"/>
-                </a:solidFill>
-                <a:latin typeface="Segoe UI"/>
-              </a:rPr>
-              <a:t>3</a:t>
+                  <a:srgbClr val="062A63"/>
+                </a:solidFill>
+                <a:latin typeface="Segoe UI"/>
+              </a:rPr>
+              <a:t>11</a:t>
             </a:r>
           </a:p>
         </p:txBody>
@@ -20961,7 +20961,7 @@
             <a:avLst/>
           </a:prstGeom>
           <a:solidFill>
-            <a:srgbClr val="14795F"/>
+            <a:srgbClr val="062A63"/>
           </a:solidFill>
           <a:ln>
             <a:noFill/>
@@ -21065,11 +21065,11 @@
             <a:r>
               <a:rPr sz="2400" b="1">
                 <a:solidFill>
-                  <a:srgbClr val="14795F"/>
-                </a:solidFill>
-                <a:latin typeface="Segoe UI"/>
-              </a:rPr>
-              <a:t>101</a:t>
+                  <a:srgbClr val="062A63"/>
+                </a:solidFill>
+                <a:latin typeface="Segoe UI"/>
+              </a:rPr>
+              <a:t>99</a:t>
             </a:r>
           </a:p>
         </p:txBody>
@@ -21253,7 +21253,7 @@
         <p:spPr>
           <a:xfrm>
             <a:off x="1600200" y="4242816"/>
-            <a:ext cx="365760" cy="155448"/>
+            <a:ext cx="1410788" cy="155448"/>
           </a:xfrm>
           <a:prstGeom prst="rect">
             <a:avLst/>
@@ -21325,7 +21325,7 @@
                 </a:solidFill>
                 <a:latin typeface="Segoe UI"/>
               </a:rPr>
-              <a:t>1</a:t>
+              <a:t>6</a:t>
             </a:r>
           </a:p>
         </p:txBody>
@@ -21425,7 +21425,7 @@
         <p:spPr>
           <a:xfrm>
             <a:off x="1600200" y="4626864"/>
-            <a:ext cx="1463040" cy="155448"/>
+            <a:ext cx="1410788" cy="155448"/>
           </a:xfrm>
           <a:prstGeom prst="rect">
             <a:avLst/>
@@ -21497,7 +21497,7 @@
                 </a:solidFill>
                 <a:latin typeface="Segoe UI"/>
               </a:rPr>
-              <a:t>4</a:t>
+              <a:t>6</a:t>
             </a:r>
           </a:p>
         </p:txBody>
@@ -21597,13 +21597,13 @@
         <p:spPr>
           <a:xfrm>
             <a:off x="1600200" y="5010912"/>
-            <a:ext cx="3291839" cy="155448"/>
+            <a:ext cx="3291840" cy="155448"/>
           </a:xfrm>
           <a:prstGeom prst="rect">
             <a:avLst/>
           </a:prstGeom>
           <a:solidFill>
-            <a:srgbClr val="B8860B"/>
+            <a:srgbClr val="D97706"/>
           </a:solidFill>
           <a:ln>
             <a:noFill/>
@@ -21669,7 +21669,7 @@
                 </a:solidFill>
                 <a:latin typeface="Segoe UI"/>
               </a:rPr>
-              <a:t>9</a:t>
+              <a:t>14</a:t>
             </a:r>
           </a:p>
         </p:txBody>
@@ -21762,7 +21762,51 @@
       </p:sp>
       <p:sp>
         <p:nvSpPr>
-          <p:cNvPr id="62" name="TextBox 61"/>
+          <p:cNvPr id="62" name="Rectangle 61"/>
+          <p:cNvSpPr/>
+          <p:nvPr/>
+        </p:nvSpPr>
+        <p:spPr>
+          <a:xfrm>
+            <a:off x="1600200" y="5394959"/>
+            <a:ext cx="1175657" cy="155448"/>
+          </a:xfrm>
+          <a:prstGeom prst="rect">
+            <a:avLst/>
+          </a:prstGeom>
+          <a:solidFill>
+            <a:srgbClr val="1E5AA8"/>
+          </a:solidFill>
+          <a:ln>
+            <a:noFill/>
+          </a:ln>
+          <a:effectLst/>
+        </p:spPr>
+        <p:style>
+          <a:lnRef idx="1">
+            <a:schemeClr val="accent1"/>
+          </a:lnRef>
+          <a:fillRef idx="3">
+            <a:schemeClr val="accent1"/>
+          </a:fillRef>
+          <a:effectRef idx="2">
+            <a:schemeClr val="accent1"/>
+          </a:effectRef>
+          <a:fontRef idx="minor">
+            <a:schemeClr val="lt1"/>
+          </a:fontRef>
+        </p:style>
+        <p:txBody>
+          <a:bodyPr rtlCol="0" anchor="ctr"/>
+          <a:lstStyle/>
+          <a:p>
+            <a:pPr algn="ctr"/>
+          </a:p>
+        </p:txBody>
+      </p:sp>
+      <p:sp>
+        <p:nvSpPr>
+          <p:cNvPr id="63" name="TextBox 62"/>
           <p:cNvSpPr txBox="1"/>
           <p:nvPr/>
         </p:nvSpPr>
@@ -21797,14 +21841,14 @@
                 </a:solidFill>
                 <a:latin typeface="Segoe UI"/>
               </a:rPr>
-              <a:t>0</a:t>
-            </a:r>
-          </a:p>
-        </p:txBody>
-      </p:sp>
-      <p:sp>
-        <p:nvSpPr>
-          <p:cNvPr id="63" name="Rectangle 62"/>
+              <a:t>5</a:t>
+            </a:r>
+          </a:p>
+        </p:txBody>
+      </p:sp>
+      <p:sp>
+        <p:nvSpPr>
+          <p:cNvPr id="64" name="Rectangle 63"/>
           <p:cNvSpPr/>
           <p:nvPr/>
         </p:nvSpPr>
@@ -21850,7 +21894,7 @@
       </p:sp>
       <p:sp>
         <p:nvSpPr>
-          <p:cNvPr id="64" name="Rectangle 63"/>
+          <p:cNvPr id="65" name="Rectangle 64"/>
           <p:cNvSpPr/>
           <p:nvPr/>
         </p:nvSpPr>
@@ -21894,7 +21938,7 @@
       </p:sp>
       <p:sp>
         <p:nvSpPr>
-          <p:cNvPr id="65" name="TextBox 64"/>
+          <p:cNvPr id="66" name="TextBox 65"/>
           <p:cNvSpPr txBox="1"/>
           <p:nvPr/>
         </p:nvSpPr>
@@ -21936,7 +21980,7 @@
       </p:sp>
       <p:sp>
         <p:nvSpPr>
-          <p:cNvPr id="66" name="Rectangle 65"/>
+          <p:cNvPr id="67" name="Rectangle 66"/>
           <p:cNvSpPr/>
           <p:nvPr/>
         </p:nvSpPr>
@@ -21949,7 +21993,7 @@
             <a:avLst/>
           </a:prstGeom>
           <a:solidFill>
-            <a:srgbClr val="14795F"/>
+            <a:srgbClr val="062A63"/>
           </a:solidFill>
           <a:ln>
             <a:noFill/>
@@ -21980,7 +22024,7 @@
       </p:sp>
       <p:sp>
         <p:nvSpPr>
-          <p:cNvPr id="67" name="TextBox 66"/>
+          <p:cNvPr id="68" name="TextBox 67"/>
           <p:cNvSpPr txBox="1"/>
           <p:nvPr/>
         </p:nvSpPr>
@@ -22022,7 +22066,7 @@
       </p:sp>
       <p:sp>
         <p:nvSpPr>
-          <p:cNvPr id="68" name="Rectangle 67"/>
+          <p:cNvPr id="69" name="Rectangle 68"/>
           <p:cNvSpPr/>
           <p:nvPr/>
         </p:nvSpPr>
@@ -22035,7 +22079,7 @@
             <a:avLst/>
           </a:prstGeom>
           <a:solidFill>
-            <a:srgbClr val="14795F"/>
+            <a:srgbClr val="062A63"/>
           </a:solidFill>
           <a:ln>
             <a:noFill/>
@@ -22066,7 +22110,7 @@
       </p:sp>
       <p:sp>
         <p:nvSpPr>
-          <p:cNvPr id="69" name="TextBox 68"/>
+          <p:cNvPr id="70" name="TextBox 69"/>
           <p:cNvSpPr txBox="1"/>
           <p:nvPr/>
         </p:nvSpPr>
@@ -22108,7 +22152,7 @@
       </p:sp>
       <p:sp>
         <p:nvSpPr>
-          <p:cNvPr id="70" name="Rectangle 69"/>
+          <p:cNvPr id="71" name="Rectangle 70"/>
           <p:cNvSpPr/>
           <p:nvPr/>
         </p:nvSpPr>
@@ -22121,7 +22165,7 @@
             <a:avLst/>
           </a:prstGeom>
           <a:solidFill>
-            <a:srgbClr val="14795F"/>
+            <a:srgbClr val="062A63"/>
           </a:solidFill>
           <a:ln>
             <a:noFill/>
@@ -22152,7 +22196,7 @@
       </p:sp>
       <p:sp>
         <p:nvSpPr>
-          <p:cNvPr id="71" name="TextBox 70"/>
+          <p:cNvPr id="72" name="TextBox 71"/>
           <p:cNvSpPr txBox="1"/>
           <p:nvPr/>
         </p:nvSpPr>
@@ -22194,7 +22238,7 @@
       </p:sp>
       <p:sp>
         <p:nvSpPr>
-          <p:cNvPr id="72" name="Rectangle 71"/>
+          <p:cNvPr id="73" name="Rectangle 72"/>
           <p:cNvSpPr/>
           <p:nvPr/>
         </p:nvSpPr>
@@ -22207,7 +22251,7 @@
             <a:avLst/>
           </a:prstGeom>
           <a:solidFill>
-            <a:srgbClr val="14795F"/>
+            <a:srgbClr val="062A63"/>
           </a:solidFill>
           <a:ln>
             <a:noFill/>
@@ -22238,7 +22282,7 @@
       </p:sp>
       <p:sp>
         <p:nvSpPr>
-          <p:cNvPr id="73" name="TextBox 72"/>
+          <p:cNvPr id="74" name="TextBox 73"/>
           <p:cNvSpPr txBox="1"/>
           <p:nvPr/>
         </p:nvSpPr>
@@ -22280,7 +22324,7 @@
       </p:sp>
       <p:sp>
         <p:nvSpPr>
-          <p:cNvPr id="74" name="Rectangle 73"/>
+          <p:cNvPr id="75" name="Rectangle 74"/>
           <p:cNvSpPr/>
           <p:nvPr/>
         </p:nvSpPr>
@@ -22293,7 +22337,7 @@
             <a:avLst/>
           </a:prstGeom>
           <a:solidFill>
-            <a:srgbClr val="14795F"/>
+            <a:srgbClr val="062A63"/>
           </a:solidFill>
           <a:ln>
             <a:noFill/>
@@ -22324,7 +22368,7 @@
       </p:sp>
       <p:sp>
         <p:nvSpPr>
-          <p:cNvPr id="75" name="TextBox 74"/>
+          <p:cNvPr id="76" name="TextBox 75"/>
           <p:cNvSpPr txBox="1"/>
           <p:nvPr/>
         </p:nvSpPr>
@@ -22366,7 +22410,7 @@
       </p:sp>
       <p:sp>
         <p:nvSpPr>
-          <p:cNvPr id="76" name="TextBox 75"/>
+          <p:cNvPr id="77" name="TextBox 76"/>
           <p:cNvSpPr txBox="1"/>
           <p:nvPr/>
         </p:nvSpPr>
@@ -22401,14 +22445,14 @@
                 </a:solidFill>
                 <a:latin typeface="Segoe UI"/>
               </a:rPr>
-              <a:t>BhuVerify · SIH26018 · Team Merge Conflict</a:t>
-            </a:r>
-          </a:p>
-        </p:txBody>
-      </p:sp>
-      <p:sp>
-        <p:nvSpPr>
-          <p:cNvPr id="77" name="TextBox 76"/>
+              <a:t>BhuVerify · SIH26018 · Team Shadow Slayers</a:t>
+            </a:r>
+          </a:p>
+        </p:txBody>
+      </p:sp>
+      <p:sp>
+        <p:nvSpPr>
+          <p:cNvPr id="78" name="TextBox 77"/>
           <p:cNvSpPr txBox="1"/>
           <p:nvPr/>
         </p:nvSpPr>
@@ -22525,7 +22569,7 @@
             <a:avLst/>
           </a:prstGeom>
           <a:solidFill>
-            <a:srgbClr val="0F5C4A"/>
+            <a:srgbClr val="0A3D91"/>
           </a:solidFill>
           <a:ln>
             <a:noFill/>
@@ -22587,7 +22631,7 @@
             <a:r>
               <a:rPr sz="1050" b="1">
                 <a:solidFill>
-                  <a:srgbClr val="14795F"/>
+                  <a:srgbClr val="062A63"/>
                 </a:solidFill>
                 <a:latin typeface="Segoe UI"/>
               </a:rPr>
@@ -22737,7 +22781,7 @@
             <a:avLst/>
           </a:prstGeom>
           <a:solidFill>
-            <a:srgbClr val="E6F2EE"/>
+            <a:srgbClr val="E8EFFA"/>
           </a:solidFill>
           <a:ln>
             <a:noFill/>
@@ -22799,7 +22843,7 @@
             <a:r>
               <a:rPr sz="1500" b="1">
                 <a:solidFill>
-                  <a:srgbClr val="0F5C4A"/>
+                  <a:srgbClr val="0A3D91"/>
                 </a:solidFill>
                 <a:latin typeface="Segoe UI"/>
               </a:rPr>
@@ -22823,7 +22867,7 @@
             <a:avLst/>
           </a:prstGeom>
           <a:solidFill>
-            <a:srgbClr val="E6F2EE"/>
+            <a:srgbClr val="E8EFFA"/>
           </a:solidFill>
           <a:ln>
             <a:noFill/>
@@ -22885,7 +22929,7 @@
             <a:r>
               <a:rPr sz="1500" b="1">
                 <a:solidFill>
-                  <a:srgbClr val="0F5C4A"/>
+                  <a:srgbClr val="0A3D91"/>
                 </a:solidFill>
                 <a:latin typeface="Segoe UI"/>
               </a:rPr>
@@ -22909,7 +22953,7 @@
             <a:avLst/>
           </a:prstGeom>
           <a:solidFill>
-            <a:srgbClr val="E6F2EE"/>
+            <a:srgbClr val="E8EFFA"/>
           </a:solidFill>
           <a:ln>
             <a:noFill/>
@@ -22971,7 +23015,7 @@
             <a:r>
               <a:rPr sz="1500" b="1">
                 <a:solidFill>
-                  <a:srgbClr val="0F5C4A"/>
+                  <a:srgbClr val="0A3D91"/>
                 </a:solidFill>
                 <a:latin typeface="Segoe UI"/>
               </a:rPr>
@@ -23017,7 +23061,7 @@
                 </a:solidFill>
                 <a:latin typeface="Segoe UI"/>
               </a:rPr>
-              <a:t>Tesseract 5.5.0 · the prototype runs real OCR, not canned text</a:t>
+              <a:t>Tesseract 5.4.0.20240606 · the prototype runs real OCR, not canned text</a:t>
             </a:r>
           </a:p>
         </p:txBody>
@@ -23121,7 +23165,7 @@
             <a:avLst/>
           </a:prstGeom>
           <a:solidFill>
-            <a:srgbClr val="14795F"/>
+            <a:srgbClr val="062A63"/>
           </a:solidFill>
           <a:ln>
             <a:noFill/>
@@ -23249,7 +23293,7 @@
             <a:avLst/>
           </a:prstGeom>
           <a:solidFill>
-            <a:srgbClr val="14795F"/>
+            <a:srgbClr val="062A63"/>
           </a:solidFill>
           <a:ln>
             <a:noFill/>
@@ -23377,7 +23421,7 @@
             <a:avLst/>
           </a:prstGeom>
           <a:solidFill>
-            <a:srgbClr val="14795F"/>
+            <a:srgbClr val="062A63"/>
           </a:solidFill>
           <a:ln>
             <a:noFill/>
@@ -23505,7 +23549,7 @@
             <a:avLst/>
           </a:prstGeom>
           <a:solidFill>
-            <a:srgbClr val="14795F"/>
+            <a:srgbClr val="062A63"/>
           </a:solidFill>
           <a:ln>
             <a:noFill/>
@@ -23655,7 +23699,7 @@
             <a:r>
               <a:rPr sz="1000" b="1">
                 <a:solidFill>
-                  <a:srgbClr val="0F5C4A"/>
+                  <a:srgbClr val="0A3D91"/>
                 </a:solidFill>
                 <a:latin typeface="Segoe UI"/>
               </a:rPr>
@@ -23857,7 +23901,7 @@
                 </a:solidFill>
                 <a:latin typeface="Segoe UI"/>
               </a:rPr>
-              <a:t>BhuVerify · SIH26018 · Team Merge Conflict</a:t>
+              <a:t>BhuVerify · SIH26018 · Team Shadow Slayers</a:t>
             </a:r>
           </a:p>
         </p:txBody>
@@ -23981,7 +24025,7 @@
             <a:avLst/>
           </a:prstGeom>
           <a:solidFill>
-            <a:srgbClr val="0F5C4A"/>
+            <a:srgbClr val="0A3D91"/>
           </a:solidFill>
           <a:ln>
             <a:noFill/>
@@ -24043,7 +24087,7 @@
             <a:r>
               <a:rPr sz="1050" b="1">
                 <a:solidFill>
-                  <a:srgbClr val="14795F"/>
+                  <a:srgbClr val="062A63"/>
                 </a:solidFill>
                 <a:latin typeface="Segoe UI"/>
               </a:rPr>
@@ -24283,7 +24327,7 @@
             <a:avLst/>
           </a:prstGeom>
           <a:solidFill>
-            <a:srgbClr val="14795F"/>
+            <a:srgbClr val="062A63"/>
           </a:solidFill>
           <a:ln>
             <a:noFill/>
@@ -24369,7 +24413,7 @@
             <a:avLst/>
           </a:prstGeom>
           <a:solidFill>
-            <a:srgbClr val="14795F"/>
+            <a:srgbClr val="062A63"/>
           </a:solidFill>
           <a:ln>
             <a:noFill/>
@@ -24455,7 +24499,7 @@
             <a:avLst/>
           </a:prstGeom>
           <a:solidFill>
-            <a:srgbClr val="14795F"/>
+            <a:srgbClr val="062A63"/>
           </a:solidFill>
           <a:ln>
             <a:noFill/>
@@ -24541,7 +24585,7 @@
             <a:avLst/>
           </a:prstGeom>
           <a:solidFill>
-            <a:srgbClr val="14795F"/>
+            <a:srgbClr val="062A63"/>
           </a:solidFill>
           <a:ln>
             <a:noFill/>
@@ -24627,7 +24671,7 @@
             <a:avLst/>
           </a:prstGeom>
           <a:solidFill>
-            <a:srgbClr val="14795F"/>
+            <a:srgbClr val="062A63"/>
           </a:solidFill>
           <a:ln>
             <a:noFill/>
@@ -24845,7 +24889,7 @@
             <a:avLst/>
           </a:prstGeom>
           <a:solidFill>
-            <a:srgbClr val="14795F"/>
+            <a:srgbClr val="062A63"/>
           </a:solidFill>
           <a:ln>
             <a:noFill/>
@@ -24931,7 +24975,7 @@
             <a:avLst/>
           </a:prstGeom>
           <a:solidFill>
-            <a:srgbClr val="14795F"/>
+            <a:srgbClr val="062A63"/>
           </a:solidFill>
           <a:ln>
             <a:noFill/>
@@ -25017,7 +25061,7 @@
             <a:avLst/>
           </a:prstGeom>
           <a:solidFill>
-            <a:srgbClr val="14795F"/>
+            <a:srgbClr val="062A63"/>
           </a:solidFill>
           <a:ln>
             <a:noFill/>
@@ -25103,7 +25147,7 @@
             <a:avLst/>
           </a:prstGeom>
           <a:solidFill>
-            <a:srgbClr val="14795F"/>
+            <a:srgbClr val="062A63"/>
           </a:solidFill>
           <a:ln>
             <a:noFill/>
@@ -25189,7 +25233,7 @@
             <a:avLst/>
           </a:prstGeom>
           <a:solidFill>
-            <a:srgbClr val="14795F"/>
+            <a:srgbClr val="062A63"/>
           </a:solidFill>
           <a:ln>
             <a:noFill/>
@@ -25337,7 +25381,7 @@
             <a:r>
               <a:rPr sz="1000" b="1">
                 <a:solidFill>
-                  <a:srgbClr val="0F5C4A"/>
+                  <a:srgbClr val="0A3D91"/>
                 </a:solidFill>
                 <a:latin typeface="Segoe UI"/>
               </a:rPr>
@@ -25379,7 +25423,7 @@
             <a:r>
               <a:rPr sz="1700" b="1">
                 <a:solidFill>
-                  <a:srgbClr val="0F5C4A"/>
+                  <a:srgbClr val="0A3D91"/>
                 </a:solidFill>
                 <a:latin typeface="Segoe UI"/>
               </a:rPr>
@@ -25581,7 +25625,7 @@
                 </a:solidFill>
                 <a:latin typeface="Segoe UI"/>
               </a:rPr>
-              <a:t>BhuVerify · SIH26018 · Team Merge Conflict</a:t>
+              <a:t>BhuVerify · SIH26018 · Team Shadow Slayers</a:t>
             </a:r>
           </a:p>
         </p:txBody>
@@ -25705,7 +25749,7 @@
             <a:avLst/>
           </a:prstGeom>
           <a:solidFill>
-            <a:srgbClr val="0F5C4A"/>
+            <a:srgbClr val="0A3D91"/>
           </a:solidFill>
           <a:ln>
             <a:noFill/>
@@ -25767,7 +25811,7 @@
             <a:r>
               <a:rPr sz="1050" b="1">
                 <a:solidFill>
-                  <a:srgbClr val="14795F"/>
+                  <a:srgbClr val="062A63"/>
                 </a:solidFill>
                 <a:latin typeface="Segoe UI"/>
               </a:rPr>
@@ -25875,7 +25919,7 @@
             <a:avLst/>
           </a:prstGeom>
           <a:solidFill>
-            <a:srgbClr val="0F5C4A"/>
+            <a:srgbClr val="0A3D91"/>
           </a:solidFill>
           <a:ln>
             <a:noFill/>
@@ -27882,7 +27926,7 @@
                 </a:solidFill>
                 <a:latin typeface="Segoe UI"/>
               </a:rPr>
-              <a:t>BhuVerify · SIH26018 · Team Merge Conflict</a:t>
+              <a:t>BhuVerify · SIH26018 · Team Shadow Slayers</a:t>
             </a:r>
           </a:p>
         </p:txBody>

</xml_diff>